<commit_message>
docs: update presentation with the final results
</commit_message>
<xml_diff>
--- a/docs/apresentacao.pptx
+++ b/docs/apresentacao.pptx
@@ -124,7 +124,7 @@
 <c:chartSpace xmlns:c="http://schemas.openxmlformats.org/drawingml/2006/chart" xmlns:a="http://schemas.openxmlformats.org/drawingml/2006/main" xmlns:r="http://schemas.openxmlformats.org/officeDocument/2006/relationships">
   <c:date1904 val="0"/>
   <c:chart>
-    <c:autoTitleDeleted val="0"/>
+    <c:autoTitleDeleted val="1"/>
     <c:plotArea>
       <c:barChart>
         <c:barDir val="bar"/>
@@ -138,102 +138,296 @@
               <c:strCache>
                 <c:ptCount val="1"/>
                 <c:pt idx="0">
-                  <c:v>Tempo (s)</c:v>
+                  <c:v>2 peers, bloco 1024 B</c:v>
                 </c:pt>
               </c:strCache>
             </c:strRef>
           </c:tx>
+          <c:spPr>
+            <a:solidFill>
+              <a:srgbClr val="2E86C1"/>
+            </a:solidFill>
+          </c:spPr>
           <c:cat>
             <c:strRef>
-              <c:f>Sheet1!$A$2:$A$9</c:f>
+              <c:f>Sheet1!$A$2:$A$7</c:f>
               <c:strCache>
-                <c:ptCount val="8"/>
+                <c:ptCount val="6"/>
                 <c:pt idx="0">
-                  <c:v>T1 · 10 KB</c:v>
+                  <c:v>10 KB</c:v>
                 </c:pt>
                 <c:pt idx="1">
-                  <c:v>T2 · 20 KB</c:v>
+                  <c:v>20 KB</c:v>
                 </c:pt>
                 <c:pt idx="2">
-                  <c:v>T3 · 1 MB</c:v>
+                  <c:v>1 MB</c:v>
                 </c:pt>
                 <c:pt idx="3">
-                  <c:v>T4 · 5 MB</c:v>
+                  <c:v>5 MB</c:v>
                 </c:pt>
                 <c:pt idx="4">
-                  <c:v>T5 · 10 MB</c:v>
+                  <c:v>10 MB</c:v>
                 </c:pt>
                 <c:pt idx="5">
-                  <c:v>T6 · 20 MB</c:v>
-                </c:pt>
-                <c:pt idx="6">
-                  <c:v>T7 · 1 MB / 4 P</c:v>
-                </c:pt>
-                <c:pt idx="7">
-                  <c:v>T8 · 5 MB / 4 P</c:v>
+                  <c:v>20 MB</c:v>
                 </c:pt>
               </c:strCache>
             </c:strRef>
           </c:cat>
           <c:val>
             <c:numRef>
-              <c:f>Sheet1!$B$2:$B$9</c:f>
+              <c:f>Sheet1!$B$2:$B$7</c:f>
               <c:numCache>
                 <c:formatCode>General</c:formatCode>
-                <c:ptCount val="8"/>
+                <c:ptCount val="6"/>
                 <c:pt idx="0">
-                  <c:v>0.202</c:v>
+                  <c:v>3</c:v>
                 </c:pt>
                 <c:pt idx="1">
-                  <c:v>0.203</c:v>
+                  <c:v>4</c:v>
                 </c:pt>
                 <c:pt idx="2">
-                  <c:v>0.503</c:v>
+                  <c:v>99</c:v>
                 </c:pt>
                 <c:pt idx="3">
-                  <c:v>0.704</c:v>
+                  <c:v>473</c:v>
                 </c:pt>
                 <c:pt idx="4">
-                  <c:v>3.216</c:v>
+                  <c:v>973</c:v>
                 </c:pt>
                 <c:pt idx="5">
-                  <c:v>2.313</c:v>
-                </c:pt>
-                <c:pt idx="6">
-                  <c:v>0.757</c:v>
-                </c:pt>
-                <c:pt idx="7">
-                  <c:v>1.26</c:v>
+                  <c:v>1856</c:v>
                 </c:pt>
               </c:numCache>
             </c:numRef>
           </c:val>
         </c:ser>
-        <c:dLbls>
-          <c:txPr>
-            <a:bodyPr/>
-            <a:lstStyle/>
-            <a:p>
-              <a:pPr>
-                <a:defRPr sz="1300"/>
-              </a:pPr>
-            </a:p>
-          </c:txPr>
-          <c:showLegendKey val="0"/>
-          <c:showVal val="1"/>
-          <c:showCatName val="0"/>
-          <c:showSerName val="0"/>
-          <c:showPercent val="0"/>
-          <c:showBubbleSize val="0"/>
-          <c:showLeaderLines val="1"/>
-        </c:dLbls>
+        <c:ser>
+          <c:idx val="1"/>
+          <c:order val="1"/>
+          <c:tx>
+            <c:strRef>
+              <c:f>Sheet1!$C$1</c:f>
+              <c:strCache>
+                <c:ptCount val="1"/>
+                <c:pt idx="0">
+                  <c:v>2 peers, bloco 4096 B</c:v>
+                </c:pt>
+              </c:strCache>
+            </c:strRef>
+          </c:tx>
+          <c:spPr>
+            <a:solidFill>
+              <a:srgbClr val="85C1E9"/>
+            </a:solidFill>
+          </c:spPr>
+          <c:cat>
+            <c:strRef>
+              <c:f>Sheet1!$A$2:$A$7</c:f>
+              <c:strCache>
+                <c:ptCount val="6"/>
+                <c:pt idx="0">
+                  <c:v>10 KB</c:v>
+                </c:pt>
+                <c:pt idx="1">
+                  <c:v>20 KB</c:v>
+                </c:pt>
+                <c:pt idx="2">
+                  <c:v>1 MB</c:v>
+                </c:pt>
+                <c:pt idx="3">
+                  <c:v>5 MB</c:v>
+                </c:pt>
+                <c:pt idx="4">
+                  <c:v>10 MB</c:v>
+                </c:pt>
+                <c:pt idx="5">
+                  <c:v>20 MB</c:v>
+                </c:pt>
+              </c:strCache>
+            </c:strRef>
+          </c:cat>
+          <c:val>
+            <c:numRef>
+              <c:f>Sheet1!$C$2:$C$7</c:f>
+              <c:numCache>
+                <c:formatCode>General</c:formatCode>
+                <c:ptCount val="6"/>
+                <c:pt idx="0">
+                  <c:v>2</c:v>
+                </c:pt>
+                <c:pt idx="1">
+                  <c:v>3</c:v>
+                </c:pt>
+                <c:pt idx="2">
+                  <c:v>27</c:v>
+                </c:pt>
+                <c:pt idx="3">
+                  <c:v>128</c:v>
+                </c:pt>
+                <c:pt idx="4">
+                  <c:v>254</c:v>
+                </c:pt>
+                <c:pt idx="5">
+                  <c:v>532</c:v>
+                </c:pt>
+              </c:numCache>
+            </c:numRef>
+          </c:val>
+        </c:ser>
+        <c:ser>
+          <c:idx val="2"/>
+          <c:order val="2"/>
+          <c:tx>
+            <c:strRef>
+              <c:f>Sheet1!$D$1</c:f>
+              <c:strCache>
+                <c:ptCount val="1"/>
+                <c:pt idx="0">
+                  <c:v>4 peers, bloco 1024 B</c:v>
+                </c:pt>
+              </c:strCache>
+            </c:strRef>
+          </c:tx>
+          <c:spPr>
+            <a:solidFill>
+              <a:srgbClr val="E67E22"/>
+            </a:solidFill>
+          </c:spPr>
+          <c:cat>
+            <c:strRef>
+              <c:f>Sheet1!$A$2:$A$7</c:f>
+              <c:strCache>
+                <c:ptCount val="6"/>
+                <c:pt idx="0">
+                  <c:v>10 KB</c:v>
+                </c:pt>
+                <c:pt idx="1">
+                  <c:v>20 KB</c:v>
+                </c:pt>
+                <c:pt idx="2">
+                  <c:v>1 MB</c:v>
+                </c:pt>
+                <c:pt idx="3">
+                  <c:v>5 MB</c:v>
+                </c:pt>
+                <c:pt idx="4">
+                  <c:v>10 MB</c:v>
+                </c:pt>
+                <c:pt idx="5">
+                  <c:v>20 MB</c:v>
+                </c:pt>
+              </c:strCache>
+            </c:strRef>
+          </c:cat>
+          <c:val>
+            <c:numRef>
+              <c:f>Sheet1!$D$2:$D$7</c:f>
+              <c:numCache>
+                <c:formatCode>General</c:formatCode>
+                <c:ptCount val="6"/>
+                <c:pt idx="0">
+                  <c:v>84</c:v>
+                </c:pt>
+                <c:pt idx="1">
+                  <c:v>105</c:v>
+                </c:pt>
+                <c:pt idx="2">
+                  <c:v>152</c:v>
+                </c:pt>
+                <c:pt idx="3">
+                  <c:v>527</c:v>
+                </c:pt>
+                <c:pt idx="4">
+                  <c:v>1106</c:v>
+                </c:pt>
+                <c:pt idx="5">
+                  <c:v>2141</c:v>
+                </c:pt>
+              </c:numCache>
+            </c:numRef>
+          </c:val>
+        </c:ser>
+        <c:ser>
+          <c:idx val="3"/>
+          <c:order val="3"/>
+          <c:tx>
+            <c:strRef>
+              <c:f>Sheet1!$E$1</c:f>
+              <c:strCache>
+                <c:ptCount val="1"/>
+                <c:pt idx="0">
+                  <c:v>4 peers, bloco 4096 B</c:v>
+                </c:pt>
+              </c:strCache>
+            </c:strRef>
+          </c:tx>
+          <c:spPr>
+            <a:solidFill>
+              <a:srgbClr val="F5CBA7"/>
+            </a:solidFill>
+          </c:spPr>
+          <c:cat>
+            <c:strRef>
+              <c:f>Sheet1!$A$2:$A$7</c:f>
+              <c:strCache>
+                <c:ptCount val="6"/>
+                <c:pt idx="0">
+                  <c:v>10 KB</c:v>
+                </c:pt>
+                <c:pt idx="1">
+                  <c:v>20 KB</c:v>
+                </c:pt>
+                <c:pt idx="2">
+                  <c:v>1 MB</c:v>
+                </c:pt>
+                <c:pt idx="3">
+                  <c:v>5 MB</c:v>
+                </c:pt>
+                <c:pt idx="4">
+                  <c:v>10 MB</c:v>
+                </c:pt>
+                <c:pt idx="5">
+                  <c:v>20 MB</c:v>
+                </c:pt>
+              </c:strCache>
+            </c:strRef>
+          </c:cat>
+          <c:val>
+            <c:numRef>
+              <c:f>Sheet1!$E$2:$E$7</c:f>
+              <c:numCache>
+                <c:formatCode>General</c:formatCode>
+                <c:ptCount val="6"/>
+                <c:pt idx="0">
+                  <c:v>26</c:v>
+                </c:pt>
+                <c:pt idx="1">
+                  <c:v>5</c:v>
+                </c:pt>
+                <c:pt idx="2">
+                  <c:v>48</c:v>
+                </c:pt>
+                <c:pt idx="3">
+                  <c:v>152</c:v>
+                </c:pt>
+                <c:pt idx="4">
+                  <c:v>290</c:v>
+                </c:pt>
+                <c:pt idx="5">
+                  <c:v>587</c:v>
+                </c:pt>
+              </c:numCache>
+            </c:numRef>
+          </c:val>
+        </c:ser>
         <c:axId val="-2068027336"/>
         <c:axId val="-2113994440"/>
       </c:barChart>
       <c:catAx>
         <c:axId val="-2068027336"/>
         <c:scaling>
-          <c:orientation val="minMax"/>
+          <c:orientation val="maxMin"/>
         </c:scaling>
         <c:delete val="0"/>
         <c:axPos val="l"/>
@@ -249,12 +443,18 @@
       </c:catAx>
       <c:valAx>
         <c:axId val="-2113994440"/>
-        <c:scaling>
-          <c:max val="3.5"/>
-        </c:scaling>
+        <c:scaling/>
         <c:delete val="0"/>
         <c:axPos val="b"/>
-        <c:majorGridlines/>
+        <c:majorGridlines>
+          <c:spPr>
+            <a:ln>
+              <a:solidFill>
+                <a:srgbClr val="3A4A63"/>
+              </a:solidFill>
+            </a:ln>
+          </c:spPr>
+        </c:majorGridlines>
         <c:majorTickMark val="out"/>
         <c:minorTickMark val="none"/>
         <c:tickLblPos val="nextTo"/>
@@ -262,6 +462,10 @@
         <c:crosses val="autoZero"/>
       </c:valAx>
     </c:plotArea>
+    <c:legend>
+      <c:legendPos val="b"/>
+      <c:overlay val="0"/>
+    </c:legend>
     <c:dispBlanksAs val="gap"/>
   </c:chart>
   <c:txPr>
@@ -269,7 +473,11 @@
     <a:lstStyle/>
     <a:p>
       <a:pPr>
-        <a:defRPr sz="1800"/>
+        <a:defRPr sz="1200">
+          <a:solidFill>
+            <a:srgbClr val="D9E1EA"/>
+          </a:solidFill>
+        </a:defRPr>
       </a:pPr>
       <a:endParaRPr lang="en-US"/>
     </a:p>
@@ -284,7 +492,7 @@
 <c:chartSpace xmlns:c="http://schemas.openxmlformats.org/drawingml/2006/chart" xmlns:a="http://schemas.openxmlformats.org/drawingml/2006/main" xmlns:r="http://schemas.openxmlformats.org/officeDocument/2006/relationships">
   <c:date1904 val="0"/>
   <c:chart>
-    <c:autoTitleDeleted val="0"/>
+    <c:autoTitleDeleted val="1"/>
     <c:plotArea>
       <c:barChart>
         <c:barDir val="col"/>
@@ -303,31 +511,48 @@
               </c:strCache>
             </c:strRef>
           </c:tx>
+          <c:spPr>
+            <a:solidFill>
+              <a:srgbClr val="1FA2A8"/>
+            </a:solidFill>
+          </c:spPr>
           <c:cat>
             <c:strRef>
-              <c:f>Sheet1!$A$2:$A$3</c:f>
+              <c:f>Sheet1!$A$2:$A$5</c:f>
               <c:strCache>
-                <c:ptCount val="2"/>
+                <c:ptCount val="4"/>
                 <c:pt idx="0">
-                  <c:v>Peer B :25001</c:v>
+                  <c:v>C ← A</c:v>
                 </c:pt>
                 <c:pt idx="1">
-                  <c:v>Peer C :25002</c:v>
+                  <c:v>C ← B</c:v>
+                </c:pt>
+                <c:pt idx="2">
+                  <c:v>D ← B</c:v>
+                </c:pt>
+                <c:pt idx="3">
+                  <c:v>D ← C</c:v>
                 </c:pt>
               </c:strCache>
             </c:strRef>
           </c:cat>
           <c:val>
             <c:numRef>
-              <c:f>Sheet1!$B$2:$B$3</c:f>
+              <c:f>Sheet1!$B$2:$B$5</c:f>
               <c:numCache>
                 <c:formatCode>General</c:formatCode>
-                <c:ptCount val="2"/>
+                <c:ptCount val="4"/>
                 <c:pt idx="0">
-                  <c:v>522</c:v>
+                  <c:v>13251</c:v>
                 </c:pt>
                 <c:pt idx="1">
-                  <c:v>502</c:v>
+                  <c:v>7229</c:v>
+                </c:pt>
+                <c:pt idx="2">
+                  <c:v>7029</c:v>
+                </c:pt>
+                <c:pt idx="3">
+                  <c:v>13451</c:v>
                 </c:pt>
               </c:numCache>
             </c:numRef>
@@ -373,12 +598,18 @@
       </c:catAx>
       <c:valAx>
         <c:axId val="-2113994440"/>
-        <c:scaling>
-          <c:max val="600.0"/>
-        </c:scaling>
+        <c:scaling/>
         <c:delete val="0"/>
         <c:axPos val="l"/>
-        <c:majorGridlines/>
+        <c:majorGridlines>
+          <c:spPr>
+            <a:ln>
+              <a:solidFill>
+                <a:srgbClr val="3A4A63"/>
+              </a:solidFill>
+            </a:ln>
+          </c:spPr>
+        </c:majorGridlines>
         <c:majorTickMark val="out"/>
         <c:minorTickMark val="none"/>
         <c:tickLblPos val="nextTo"/>
@@ -393,7 +624,11 @@
     <a:lstStyle/>
     <a:p>
       <a:pPr>
-        <a:defRPr sz="1800"/>
+        <a:defRPr sz="1200">
+          <a:solidFill>
+            <a:srgbClr val="D9E1EA"/>
+          </a:solidFill>
+        </a:defRPr>
       </a:pPr>
       <a:endParaRPr lang="en-US"/>
     </a:p>
@@ -4834,7 +5069,7 @@
               </a:defRPr>
             </a:pPr>
             <a:r>
-              <a:t>Trabalho Prático 2  •  C++17 / Linux  •  Apresentação de 20 minutos</a:t>
+              <a:t>Trabalho Prático 2  •  C++17 / Linux  •  2026/2</a:t>
             </a:r>
           </a:p>
         </p:txBody>
@@ -5044,7 +5279,7 @@
               </a:defRPr>
             </a:pPr>
             <a:r>
-              <a:t>Resultados: tempos dos oito testes</a:t>
+              <a:t>Resultados: tempo médio por cenário</a:t>
             </a:r>
           </a:p>
         </p:txBody>
@@ -5082,7 +5317,7 @@
               </a:defRPr>
             </a:pPr>
             <a:r>
-              <a:t>Tempo observado por cenário — segundos (uma execução por configuração)</a:t>
+              <a:t>Tempo do último leecher em ms — média de 5 execuções por cenário</a:t>
             </a:r>
           </a:p>
         </p:txBody>
@@ -5318,7 +5553,7 @@
               </a:defRPr>
             </a:pPr>
             <a:r>
-              <a:t>8 de 8</a:t>
+              <a:t>120 de 120</a:t>
             </a:r>
           </a:p>
         </p:txBody>
@@ -5356,7 +5591,7 @@
               </a:defRPr>
             </a:pPr>
             <a:r>
-              <a:t>cenários com SHA-256 válido</a:t>
+              <a:t>execuções com tamanho, SHA-256 e origens corretos</a:t>
             </a:r>
           </a:p>
         </p:txBody>
@@ -5498,7 +5733,7 @@
               </a:defRPr>
             </a:pPr>
             <a:r>
-              <a:t>Peer D • arquivo de 1 MB • 1024 blocos de 1024 bytes</a:t>
+              <a:t>4 peers • arquivo de 20 MB • 20480 blocos de 1024 bytes</a:t>
             </a:r>
           </a:p>
         </p:txBody>
@@ -5592,7 +5827,7 @@
               </a:defRPr>
             </a:pPr>
             <a:r>
-              <a:t>50,98% de B  •  49,02% de C</a:t>
+              <a:t>C recebeu 35% de B  •  D recebeu 34% de B e 66% de C</a:t>
             </a:r>
           </a:p>
         </p:txBody>
@@ -5772,7 +6007,7 @@
               </a:defRPr>
             </a:pPr>
             <a:r>
-              <a:t>• Evidência: B e C compartilharam blocos com D; o Seeder não foi a única fonte.</a:t>
+              <a:t>• Blocos de 4 KB: 3,5 a 3,8 vezes mais rápidos (uma conexão por bloco).</a:t>
             </a:r>
           </a:p>
           <a:p>
@@ -5787,7 +6022,7 @@
               </a:defRPr>
             </a:pPr>
             <a:r>
-              <a:t>• Os oito arquivos reconstruídos passaram na verificação de integridade.</a:t>
+              <a:t>• Com 4 peers, B é o mais lento (2141 ms em 20 MB): só conhece A.</a:t>
             </a:r>
           </a:p>
           <a:p>
@@ -5802,7 +6037,7 @@
               </a:defRPr>
             </a:pPr>
             <a:r>
-              <a:t>• Tempos variaram de 0,202 s a 3,216 s, sem repetição estatística.</a:t>
+              <a:t>• C e D usam dois vizinhos e terminam antes (1478 e 1499 ms).</a:t>
             </a:r>
           </a:p>
           <a:p>
@@ -5817,7 +6052,7 @@
               </a:defRPr>
             </a:pPr>
             <a:r>
-              <a:t>• Localhost não representa latência, perda ou congestionamento de uma rede física.</a:t>
+              <a:t>• Falha: sem B, D terminou com C e registrou o vizinho inacessível.</a:t>
             </a:r>
           </a:p>
           <a:p>
@@ -5832,7 +6067,7 @@
               </a:defRPr>
             </a:pPr>
             <a:r>
-              <a:t>• Não é possível inferir ganho por número de Peers ou tamanho de bloco isoladamente.</a:t>
+              <a:t>• Localhost não tem a latência, as perdas e a banda de uma rede real.</a:t>
             </a:r>
           </a:p>
         </p:txBody>
@@ -6012,7 +6247,7 @@
               </a:defRPr>
             </a:pPr>
             <a:r>
-              <a:t>• Sistema P2P funcional: fragmentação, concorrência, redistribuição e remontagem.</a:t>
+              <a:t>• Requisitos atendidos: simetria, fragmentação, protocolo e montagem.</a:t>
             </a:r>
           </a:p>
           <a:p>
@@ -6027,7 +6262,7 @@
               </a:defRPr>
             </a:pPr>
             <a:r>
-              <a:t>• Logs confirmam que Peers intermediários fornecem blocos.</a:t>
+              <a:t>• Logs comprovam a troca entre leechers e a recuperação de falha.</a:t>
             </a:r>
           </a:p>
           <a:p>
@@ -6042,7 +6277,7 @@
               </a:defRPr>
             </a:pPr>
             <a:r>
-              <a:t>• Próximos passos: experimentos repetidos, máquinas distintas, retomada e segurança.</a:t>
+              <a:t>• Próximos passos: conexão persistente, aviso de blocos e rede real.</a:t>
             </a:r>
           </a:p>
           <a:p>
@@ -6057,7 +6292,7 @@
               </a:defRPr>
             </a:pPr>
             <a:r>
-              <a:t>• Código-fonte: inserir URL do repositório antes da entrega.</a:t>
+              <a:t>• Código-fonte: github.com/allinesferreira/CEFET-SD_TP2</a:t>
             </a:r>
           </a:p>
         </p:txBody>
@@ -7575,7 +7810,7 @@
               </a:defRPr>
             </a:pPr>
             <a:r>
-              <a:t>• C++17 e sockets TCP/IPv4 (POSIX); compilação via g++/Makefile.</a:t>
+              <a:t>• C++17 e sockets TCP/IPv4 (POSIX); compilação com g++ e Makefile.</a:t>
             </a:r>
           </a:p>
           <a:p>
@@ -7590,7 +7825,7 @@
               </a:defRPr>
             </a:pPr>
             <a:r>
-              <a:t>• Servidor acompanha conexões com select() e atende clientes com threads.</a:t>
+              <a:t>• Servidor em uma única thread, com sockets não bloqueantes e poll().</a:t>
             </a:r>
           </a:p>
           <a:p>
@@ -7605,7 +7840,7 @@
               </a:defRPr>
             </a:pPr>
             <a:r>
-              <a:t>• Mutex protege mapas have (disponíveis) e claimed (reservados).</a:t>
+              <a:t>• Uma thread de download por vizinho, pedindo blocos em ordem aleatória.</a:t>
             </a:r>
           </a:p>
           <a:p>
@@ -7620,7 +7855,22 @@
               </a:defRPr>
             </a:pPr>
             <a:r>
-              <a:t>• pread/pwrite gravam blocos por deslocamento; OpenSSL verifica SHA-256.</a:t>
+              <a:t>• Mutex protege os mapas have (gravados) e claimed (em download).</a:t>
+            </a:r>
+          </a:p>
+          <a:p>
+            <a:pPr>
+              <a:spcAft>
+                <a:spcPts val="1400"/>
+              </a:spcAft>
+              <a:defRPr sz="2100" b="0">
+                <a:solidFill>
+                  <a:srgbClr val="F5F8FC"/>
+                </a:solidFill>
+              </a:defRPr>
+            </a:pPr>
+            <a:r>
+              <a:t>• pread/pwrite gravam por deslocamento; OpenSSL confere o SHA-256.</a:t>
             </a:r>
           </a:p>
         </p:txBody>
@@ -7800,7 +8050,7 @@
               </a:defRPr>
             </a:pPr>
             <a:r>
-              <a:t>• M — solicita metadados (P2PMETA1): nome, tamanho, blocos e hashes.</a:t>
+              <a:t>• Toda requisição: comando de 1 byte + IP e porta de quem pede.</a:t>
             </a:r>
           </a:p>
           <a:p>
@@ -7815,7 +8065,7 @@
               </a:defRPr>
             </a:pPr>
             <a:r>
-              <a:t>• H — consulta mapa de disponibilidade: quais blocos o vizinho possui.</a:t>
+              <a:t>• M — metadados P2PMETA1: nome, tamanho, bloco e hashes.</a:t>
             </a:r>
           </a:p>
           <a:p>
@@ -7830,7 +8080,7 @@
               </a:defRPr>
             </a:pPr>
             <a:r>
-              <a:t>• G — solicita um bloco pelo índice; resposta contém tamanho e dados.</a:t>
+              <a:t>• H — mapa de disponibilidade: um byte por bloco do arquivo.</a:t>
             </a:r>
           </a:p>
           <a:p>
@@ -7845,7 +8095,22 @@
               </a:defRPr>
             </a:pPr>
             <a:r>
-              <a:t>• sendall/recvall tratam leituras e escritas parciais em TCP.</a:t>
+              <a:t>• G — bloco pelo índice; resposta com tamanho (uint32) e dados.</a:t>
+            </a:r>
+          </a:p>
+          <a:p>
+            <a:pPr>
+              <a:spcAft>
+                <a:spcPts val="1400"/>
+              </a:spcAft>
+              <a:defRPr sz="2100" b="0">
+                <a:solidFill>
+                  <a:srgbClr val="F5F8FC"/>
+                </a:solidFill>
+              </a:defRPr>
+            </a:pPr>
+            <a:r>
+              <a:t>• Tamanho 0 indica pedido negado; logs registram origem e destino.</a:t>
             </a:r>
           </a:p>
         </p:txBody>
@@ -8025,7 +8290,7 @@
               </a:defRPr>
             </a:pPr>
             <a:r>
-              <a:t>• 1. Obter metadados e identificar blocos faltantes.</a:t>
+              <a:t>• 1. Obter os metadados de um vizinho e criar o arquivo .part.</a:t>
             </a:r>
           </a:p>
           <a:p>
@@ -8040,7 +8305,7 @@
               </a:defRPr>
             </a:pPr>
             <a:r>
-              <a:t>• 2. Consultar disponibilidade dos vizinhos e reservar um índice.</a:t>
+              <a:t>• 2. Consultar o mapa de cada vizinho e reservar um bloco que falta.</a:t>
             </a:r>
           </a:p>
           <a:p>
@@ -8055,7 +8320,7 @@
               </a:defRPr>
             </a:pPr>
             <a:r>
-              <a:t>• 3. Receber bloco, validar hash individual e gravar em .part.</a:t>
+              <a:t>• 3. Receber o bloco, conferir o SHA-256 e gravar na posição certa.</a:t>
             </a:r>
           </a:p>
           <a:p>
@@ -8070,7 +8335,7 @@
               </a:defRPr>
             </a:pPr>
             <a:r>
-              <a:t>• 4. Publicar o bloco para outros Peers; repetir até completar.</a:t>
+              <a:t>• 4. Marcar o bloco em have: ele já pode ser servido a outros peers.</a:t>
             </a:r>
           </a:p>
           <a:p>
@@ -8085,7 +8350,7 @@
               </a:defRPr>
             </a:pPr>
             <a:r>
-              <a:t>• 5. Conferir SHA-256 integral e finalizar o arquivo.</a:t>
+              <a:t>• 5. Ao completar, conferir o SHA-256 do arquivo e renomear o .part.</a:t>
             </a:r>
           </a:p>
         </p:txBody>
@@ -8265,7 +8530,7 @@
               </a:defRPr>
             </a:pPr>
             <a:r>
-              <a:t>• Oito cenários em Linux, usando 127.0.0.1 (loopback).</a:t>
+              <a:t>• 24 cenários: 2 e 4 peers × blocos de 1 e 4 KB × arquivos de 10 KB a 20 MB.</a:t>
             </a:r>
           </a:p>
           <a:p>
@@ -8280,7 +8545,7 @@
               </a:defRPr>
             </a:pPr>
             <a:r>
-              <a:t>• 2 ou 4 Peers; blocos de 1024 ou 4096 bytes.</a:t>
+              <a:t>• 5 execuções por cenário (120 no total), com arquivo aleatório novo.</a:t>
             </a:r>
           </a:p>
           <a:p>
@@ -8295,7 +8560,7 @@
               </a:defRPr>
             </a:pPr>
             <a:r>
-              <a:t>• Arquivos: 10 KB, 20 KB, 1 MB, 5 MB, 10 MB e 20 MB.</a:t>
+              <a:t>• Verificações: tamanho, SHA-256 e origem de cada bloco pelos logs.</a:t>
             </a:r>
           </a:p>
           <a:p>
@@ -8310,7 +8575,7 @@
               </a:defRPr>
             </a:pPr>
             <a:r>
-              <a:t>• Script Python gera arquivos, inicia processos, mede tempo e compara SHA-256.</a:t>
+              <a:t>• Falha: B encerrado com SIGKILL quando D tem 25% dos blocos.</a:t>
             </a:r>
           </a:p>
           <a:p>
@@ -8325,7 +8590,7 @@
               </a:defRPr>
             </a:pPr>
             <a:r>
-              <a:t>• Uma execução por cenário; medições não isolam efeitos individuais.</a:t>
+              <a:t>• Linux, 127.0.0.1; cada peer mede seu tempo até o último bloco.</a:t>
             </a:r>
           </a:p>
         </p:txBody>

</xml_diff>

<commit_message>
docs: update presentation with the new results
</commit_message>
<xml_diff>
--- a/docs/apresentacao.pptx
+++ b/docs/apresentacao.pptx
@@ -181,22 +181,22 @@
                 <c:formatCode>General</c:formatCode>
                 <c:ptCount val="6"/>
                 <c:pt idx="0">
-                  <c:v>3</c:v>
+                  <c:v>4</c:v>
                 </c:pt>
                 <c:pt idx="1">
-                  <c:v>4</c:v>
+                  <c:v>5</c:v>
                 </c:pt>
                 <c:pt idx="2">
-                  <c:v>99</c:v>
+                  <c:v>148</c:v>
                 </c:pt>
                 <c:pt idx="3">
-                  <c:v>473</c:v>
+                  <c:v>705</c:v>
                 </c:pt>
                 <c:pt idx="4">
-                  <c:v>973</c:v>
+                  <c:v>1345</c:v>
                 </c:pt>
                 <c:pt idx="5">
-                  <c:v>1856</c:v>
+                  <c:v>2660</c:v>
                 </c:pt>
               </c:numCache>
             </c:numRef>
@@ -254,22 +254,22 @@
                 <c:formatCode>General</c:formatCode>
                 <c:ptCount val="6"/>
                 <c:pt idx="0">
-                  <c:v>2</c:v>
+                  <c:v>3</c:v>
                 </c:pt>
                 <c:pt idx="1">
-                  <c:v>3</c:v>
+                  <c:v>4</c:v>
                 </c:pt>
                 <c:pt idx="2">
-                  <c:v>27</c:v>
+                  <c:v>40</c:v>
                 </c:pt>
                 <c:pt idx="3">
-                  <c:v>128</c:v>
+                  <c:v>185</c:v>
                 </c:pt>
                 <c:pt idx="4">
-                  <c:v>254</c:v>
+                  <c:v>388</c:v>
                 </c:pt>
                 <c:pt idx="5">
-                  <c:v>532</c:v>
+                  <c:v>760</c:v>
                 </c:pt>
               </c:numCache>
             </c:numRef>
@@ -327,22 +327,22 @@
                 <c:formatCode>General</c:formatCode>
                 <c:ptCount val="6"/>
                 <c:pt idx="0">
-                  <c:v>84</c:v>
+                  <c:v>5</c:v>
                 </c:pt>
                 <c:pt idx="1">
-                  <c:v>105</c:v>
+                  <c:v>6</c:v>
                 </c:pt>
                 <c:pt idx="2">
-                  <c:v>152</c:v>
+                  <c:v>164</c:v>
                 </c:pt>
                 <c:pt idx="3">
-                  <c:v>527</c:v>
+                  <c:v>790</c:v>
                 </c:pt>
                 <c:pt idx="4">
-                  <c:v>1106</c:v>
+                  <c:v>1472</c:v>
                 </c:pt>
                 <c:pt idx="5">
-                  <c:v>2141</c:v>
+                  <c:v>2860</c:v>
                 </c:pt>
               </c:numCache>
             </c:numRef>
@@ -400,22 +400,22 @@
                 <c:formatCode>General</c:formatCode>
                 <c:ptCount val="6"/>
                 <c:pt idx="0">
-                  <c:v>26</c:v>
+                  <c:v>7</c:v>
                 </c:pt>
                 <c:pt idx="1">
-                  <c:v>5</c:v>
+                  <c:v>7</c:v>
                 </c:pt>
                 <c:pt idx="2">
-                  <c:v>48</c:v>
+                  <c:v>51</c:v>
                 </c:pt>
                 <c:pt idx="3">
-                  <c:v>152</c:v>
+                  <c:v>218</c:v>
                 </c:pt>
                 <c:pt idx="4">
-                  <c:v>290</c:v>
+                  <c:v>453</c:v>
                 </c:pt>
                 <c:pt idx="5">
-                  <c:v>587</c:v>
+                  <c:v>852</c:v>
                 </c:pt>
               </c:numCache>
             </c:numRef>
@@ -543,16 +543,16 @@
                 <c:formatCode>General</c:formatCode>
                 <c:ptCount val="4"/>
                 <c:pt idx="0">
-                  <c:v>13251</c:v>
+                  <c:v>13063</c:v>
                 </c:pt>
                 <c:pt idx="1">
-                  <c:v>7229</c:v>
+                  <c:v>7417</c:v>
                 </c:pt>
                 <c:pt idx="2">
-                  <c:v>7029</c:v>
+                  <c:v>6693</c:v>
                 </c:pt>
                 <c:pt idx="3">
-                  <c:v>13451</c:v>
+                  <c:v>13787</c:v>
                 </c:pt>
               </c:numCache>
             </c:numRef>
@@ -5591,7 +5591,7 @@
               </a:defRPr>
             </a:pPr>
             <a:r>
-              <a:t>execuções com tamanho, SHA-256 e origens corretos</a:t>
+              <a:t>execuções com tamanho, SHA-256, metadados e origens corretos</a:t>
             </a:r>
           </a:p>
         </p:txBody>
@@ -5827,7 +5827,7 @@
               </a:defRPr>
             </a:pPr>
             <a:r>
-              <a:t>C recebeu 35% de B  •  D recebeu 34% de B e 66% de C</a:t>
+              <a:t>C recebeu 36% de B  •  D recebeu 33% de B e 67% de C</a:t>
             </a:r>
           </a:p>
         </p:txBody>
@@ -6007,7 +6007,7 @@
               </a:defRPr>
             </a:pPr>
             <a:r>
-              <a:t>• Blocos de 4 KB: 3,5 a 3,8 vezes mais rápidos (uma conexão por bloco).</a:t>
+              <a:t>• Blocos de 4 KB: 3,3 a 3,8 vezes mais rápidos (uma conexão por bloco).</a:t>
             </a:r>
           </a:p>
           <a:p>
@@ -6022,7 +6022,7 @@
               </a:defRPr>
             </a:pPr>
             <a:r>
-              <a:t>• Com 4 peers, B é o mais lento (2141 ms em 20 MB): só conhece A.</a:t>
+              <a:t>• Com 4 peers, B é o mais lento (2860 ms em 20 MB): só conhece A.</a:t>
             </a:r>
           </a:p>
           <a:p>
@@ -6037,7 +6037,7 @@
               </a:defRPr>
             </a:pPr>
             <a:r>
-              <a:t>• C e D usam dois vizinhos e terminam antes (1478 e 1499 ms).</a:t>
+              <a:t>• C e D usam dois vizinhos e terminam antes (1898 e 1953 ms).</a:t>
             </a:r>
           </a:p>
           <a:p>
@@ -8560,7 +8560,7 @@
               </a:defRPr>
             </a:pPr>
             <a:r>
-              <a:t>• Verificações: tamanho, SHA-256 e origem de cada bloco pelos logs.</a:t>
+              <a:t>• Verificações: tamanho, SHA-256, metadados e origem de cada bloco.</a:t>
             </a:r>
           </a:p>
           <a:p>

</xml_diff>